<commit_message>
Restore pipeline figure, fix left-column overflow, enlarge fonts/figures
Addressed layout feedback on the KCA-template poster (both LaTeX & PPTX):
- Restore the missing 4-layer LLM-refinement pipeline diagram (그림 1).
- Fix the left-column figure overflowing the bottom: place pipeline and
  funnel side by side in 연구방법 instead of one full-width funnel.
- Enlarge body fonts to fill each section box (서론 34 / 목표 32 / 이론 30 /
  방법 28 / 결과 29 / 논의 30pt) and widen result figures to column width.
- Renumber figures (1 pipeline, 2 funnel, 3 overview, 4 process; 표 1).
- PPTX: add pipeline image + figure captions so the funnel numbers
  (3,652 / 479 / 451 / 9.9%) remain as text; all numbers verified intact.
- A0 confirmed (841x1189mm); no vbox overflow.

Co-Authored-By: Claude Opus 4.8 <noreply@anthropic.com>
</commit_message>
<xml_diff>
--- a/kca/poster_kca_template.pptx
+++ b/kca/poster_kca_template.pptx
@@ -7379,8 +7379,8 @@
         </p:nvSpPr>
         <p:spPr>
           <a:xfrm>
-            <a:off x="1764000" y="33696000"/>
-            <a:ext cx="12420000" cy="3312000"/>
+            <a:off x="1764000" y="33552000"/>
+            <a:ext cx="12420000" cy="2232000"/>
           </a:xfrm>
           <a:prstGeom prst="rect">
             <a:avLst/>
@@ -7402,7 +7402,7 @@
               <a:defRPr/>
             </a:pPr>
             <a:r>
-              <a:rPr sz="2300" b="0">
+              <a:rPr sz="2200" b="0">
                 <a:solidFill>
                   <a:srgbClr val="2C2C2C"/>
                 </a:solidFill>
@@ -7410,7 +7410,7 @@
                 <a:ea typeface="맑은 고딕"/>
                 <a:cs typeface="맑은 고딕"/>
               </a:rPr>
-              <a:t>자료는 X 공개 한국어 글에서 모았고, 사용자명과 외부 식별자는 수집 단계에서 자동으로 가렸다. 질의는 정밀·확장·맥락 점검·누적 확장의 네 층으로 설계했으며, 회수된 게시물은 2010년 9월부터 2026년 4월까지 약 15년 7개월에 걸쳐 있다. 정제는 사전 오염 제거·규칙 분류·LLM 판정·보수적 확정의 네 층을 거쳐 원자료 3,652건을 관련성 유지본 479건, 엄격 확정본 451건, 본문 코퍼스 361건으로 좁혔다. 결과의 안정성은 부트스트랩 재표집과 상위 질의군을 하나씩 빼는 제외 점검으로 확인했다.</a:t>
+              <a:t>자료는 X 공개 한국어 글에서 모았다(사용자명·외부 식별자 자동 비식별). 질의는 정밀·확장·맥락 점검·누적 확장의 네 층으로 설계했고, 회수 게시물은 2010년 9월~2026년 4월(약 15년 7개월)에 걸쳐 있다. 아래 LLM 보조 4층 정제 절차로 원자료를 좁혀 본문 코퍼스를 확정했다.</a:t>
             </a:r>
           </a:p>
         </p:txBody>
@@ -7536,7 +7536,7 @@
       </p:sp>
       <p:pic>
         <p:nvPicPr>
-          <p:cNvPr id="57" name="Picture 56" descr="corpus_funnel.png"/>
+          <p:cNvPr id="57" name="Picture 56" descr="pipeline.png"/>
           <p:cNvPicPr>
             <a:picLocks noChangeAspect="1"/>
           </p:cNvPicPr>
@@ -7550,8 +7550,8 @@
         </p:blipFill>
         <p:spPr>
           <a:xfrm>
-            <a:off x="4140000" y="37080000"/>
-            <a:ext cx="7380000" cy="4122343"/>
+            <a:off x="1728000" y="36000000"/>
+            <a:ext cx="6012000" cy="3526592"/>
           </a:xfrm>
           <a:prstGeom prst="rect">
             <a:avLst/>
@@ -7560,7 +7560,7 @@
       </p:pic>
       <p:pic>
         <p:nvPicPr>
-          <p:cNvPr id="58" name="Picture 57" descr="corpus_overview.png"/>
+          <p:cNvPr id="58" name="Picture 57" descr="corpus_funnel.png"/>
           <p:cNvPicPr>
             <a:picLocks noChangeAspect="1"/>
           </p:cNvPicPr>
@@ -7568,6 +7568,98 @@
         </p:nvPicPr>
         <p:blipFill>
           <a:blip r:embed="rId6"/>
+          <a:stretch>
+            <a:fillRect/>
+          </a:stretch>
+        </p:blipFill>
+        <p:spPr>
+          <a:xfrm>
+            <a:off x="8028000" y="36432000"/>
+            <a:ext cx="6120000" cy="3418529"/>
+          </a:xfrm>
+          <a:prstGeom prst="rect">
+            <a:avLst/>
+          </a:prstGeom>
+        </p:spPr>
+      </p:pic>
+      <p:sp>
+        <p:nvSpPr>
+          <p:cNvPr id="59" name="TextBox 58"/>
+          <p:cNvSpPr txBox="1"/>
+          <p:nvPr/>
+        </p:nvSpPr>
+        <p:spPr>
+          <a:xfrm>
+            <a:off x="1728000" y="39600000"/>
+            <a:ext cx="6012000" cy="504000"/>
+          </a:xfrm>
+          <a:prstGeom prst="rect">
+            <a:avLst/>
+          </a:prstGeom>
+          <a:noFill/>
+        </p:spPr>
+        <p:txBody>
+          <a:bodyPr wrap="square">
+            <a:spAutoFit/>
+          </a:bodyPr>
+          <a:lstStyle/>
+          <a:p>
+            <a:r>
+              <a:rPr sz="1400" i="1">
+                <a:solidFill>
+                  <a:srgbClr val="2C2C2C"/>
+                </a:solidFill>
+                <a:latin typeface="맑은 고딕"/>
+              </a:rPr>
+              <a:t>그림 1. LLM 보조 4층 정제 절차.</a:t>
+            </a:r>
+          </a:p>
+        </p:txBody>
+      </p:sp>
+      <p:sp>
+        <p:nvSpPr>
+          <p:cNvPr id="60" name="TextBox 59"/>
+          <p:cNvSpPr txBox="1"/>
+          <p:nvPr/>
+        </p:nvSpPr>
+        <p:spPr>
+          <a:xfrm>
+            <a:off x="8028000" y="39888000"/>
+            <a:ext cx="6120000" cy="504000"/>
+          </a:xfrm>
+          <a:prstGeom prst="rect">
+            <a:avLst/>
+          </a:prstGeom>
+          <a:noFill/>
+        </p:spPr>
+        <p:txBody>
+          <a:bodyPr wrap="square">
+            <a:spAutoFit/>
+          </a:bodyPr>
+          <a:lstStyle/>
+          <a:p>
+            <a:r>
+              <a:rPr sz="1400" i="1">
+                <a:solidFill>
+                  <a:srgbClr val="2C2C2C"/>
+                </a:solidFill>
+                <a:latin typeface="맑은 고딕"/>
+              </a:rPr>
+              <a:t>그림 2. 원자료 3,652건 → 본문 코퍼스 361건(9.9%). 관련성 유지본 479·엄격 확정본 451건 경유.</a:t>
+            </a:r>
+          </a:p>
+        </p:txBody>
+      </p:sp>
+      <p:pic>
+        <p:nvPicPr>
+          <p:cNvPr id="61" name="Picture 60" descr="corpus_overview.png"/>
+          <p:cNvPicPr>
+            <a:picLocks noChangeAspect="1"/>
+          </p:cNvPicPr>
+          <p:nvPr/>
+        </p:nvPicPr>
+        <p:blipFill>
+          <a:blip r:embed="rId7"/>
           <a:stretch>
             <a:fillRect/>
           </a:stretch>
@@ -7584,7 +7676,7 @@
       </p:pic>
       <p:sp>
         <p:nvSpPr>
-          <p:cNvPr id="59" name="TextBox 58"/>
+          <p:cNvPr id="62" name="TextBox 61"/>
           <p:cNvSpPr txBox="1"/>
           <p:nvPr/>
         </p:nvSpPr>
@@ -7636,7 +7728,7 @@
       </p:sp>
       <p:graphicFrame>
         <p:nvGraphicFramePr>
-          <p:cNvPr id="60" name="Table 59"/>
+          <p:cNvPr id="63" name="Table 62"/>
           <p:cNvGraphicFramePr>
             <a:graphicFrameLocks noGrp="1"/>
           </p:cNvGraphicFramePr>
@@ -7973,7 +8065,7 @@
       </p:graphicFrame>
       <p:sp>
         <p:nvSpPr>
-          <p:cNvPr id="61" name="TextBox 60"/>
+          <p:cNvPr id="64" name="TextBox 63"/>
           <p:cNvSpPr txBox="1"/>
           <p:nvPr/>
         </p:nvSpPr>
@@ -8025,14 +8117,14 @@
       </p:sp>
       <p:pic>
         <p:nvPicPr>
-          <p:cNvPr id="62" name="Picture 61" descr="process_contrast.png"/>
+          <p:cNvPr id="65" name="Picture 64" descr="process_contrast.png"/>
           <p:cNvPicPr>
             <a:picLocks noChangeAspect="1"/>
           </p:cNvPicPr>
           <p:nvPr/>
         </p:nvPicPr>
         <p:blipFill>
-          <a:blip r:embed="rId7"/>
+          <a:blip r:embed="rId8"/>
           <a:stretch>
             <a:fillRect/>
           </a:stretch>

</xml_diff>

<commit_message>
Reposition section bars to content; restore full-width pipeline
Per feedback that 연구방법 was cramped (forcing pipeline abbreviation):
- Move the left section bars to give each box content-appropriate height
  (2.연구목표→430, II.이론배경→520, III.연구방법→730mm) by shifting the
  template shapes in the PPTX and re-rendering the background.
- Restore the 4-layer pipeline at full column width with the FULL box
  descriptions (법률·입시·성형 / 검토 사례의 / 글쓴이 본인 경험으로 한정)
  that had been trimmed in the side-by-side layout; funnel below it.
- Apply the same bar moves + full pipeline to the PPTX deliverable.
- Re-fit per-section fonts; no overflow, no bar/content overlap.

Co-Authored-By: Claude Opus 4.8 <noreply@anthropic.com>
</commit_message>
<xml_diff>
--- a/kca/poster_kca_template.pptx
+++ b/kca/poster_kca_template.pptx
@@ -6655,7 +6655,7 @@
         </p:nvGrpSpPr>
         <p:grpSpPr>
           <a:xfrm>
-            <a:off x="1741743" y="17363052"/>
+            <a:off x="1741743" y="15480000"/>
             <a:ext cx="8398170" cy="698261"/>
             <a:chOff x="2075738" y="15366711"/>
             <a:chExt cx="8398170" cy="698261"/>
@@ -6767,7 +6767,7 @@
         </p:blipFill>
         <p:spPr>
           <a:xfrm>
-            <a:off x="1147126" y="22965707"/>
+            <a:off x="1147126" y="18720000"/>
             <a:ext cx="12780000" cy="1231000"/>
           </a:xfrm>
           <a:prstGeom prst="rect">
@@ -6789,7 +6789,7 @@
         </p:nvSpPr>
         <p:spPr>
           <a:xfrm>
-            <a:off x="1722700" y="23152293"/>
+            <a:off x="1722700" y="18900000"/>
             <a:ext cx="6106606" cy="888695"/>
           </a:xfrm>
           <a:prstGeom prst="rect">
@@ -6952,7 +6952,7 @@
         </p:blipFill>
         <p:spPr>
           <a:xfrm>
-            <a:off x="1278353" y="31992309"/>
+            <a:off x="1278353" y="26280000"/>
             <a:ext cx="12780000" cy="1242243"/>
           </a:xfrm>
           <a:prstGeom prst="rect">
@@ -6974,7 +6974,7 @@
         </p:nvSpPr>
         <p:spPr>
           <a:xfrm>
-            <a:off x="1786178" y="32121747"/>
+            <a:off x="1786178" y="26388000"/>
             <a:ext cx="7198431" cy="888695"/>
           </a:xfrm>
           <a:prstGeom prst="rect">
@@ -7111,7 +7111,7 @@
         <p:spPr>
           <a:xfrm>
             <a:off x="1872000" y="9000000"/>
-            <a:ext cx="12420000" cy="8820000"/>
+            <a:ext cx="12420000" cy="5760000"/>
           </a:xfrm>
           <a:prstGeom prst="rect">
             <a:avLst/>
@@ -7133,7 +7133,7 @@
               <a:defRPr/>
             </a:pPr>
             <a:r>
-              <a:rPr sz="2600" b="0">
+              <a:rPr sz="2300" b="0">
                 <a:solidFill>
                   <a:srgbClr val="2C2C2C"/>
                 </a:solidFill>
@@ -7160,8 +7160,8 @@
         </p:nvSpPr>
         <p:spPr>
           <a:xfrm>
-            <a:off x="1980000" y="18432000"/>
-            <a:ext cx="12420000" cy="4248000"/>
+            <a:off x="1980000" y="16380000"/>
+            <a:ext cx="12420000" cy="2160000"/>
           </a:xfrm>
           <a:prstGeom prst="rect">
             <a:avLst/>
@@ -7183,7 +7183,7 @@
               <a:defRPr/>
             </a:pPr>
             <a:r>
-              <a:rPr sz="2600" b="1">
+              <a:rPr sz="2200" b="1">
                 <a:solidFill>
                   <a:srgbClr val="2C2C2C"/>
                 </a:solidFill>
@@ -7194,7 +7194,7 @@
               <a:t>목적 1.  </a:t>
             </a:r>
             <a:r>
-              <a:rPr sz="2600" b="0">
+              <a:rPr sz="2200" b="0">
                 <a:solidFill>
                   <a:srgbClr val="2C2C2C"/>
                 </a:solidFill>
@@ -7212,7 +7212,7 @@
               </a:spcAft>
             </a:pPr>
             <a:r>
-              <a:rPr sz="2600" b="1">
+              <a:rPr sz="2200" b="1">
                 <a:solidFill>
                   <a:srgbClr val="2C2C2C"/>
                 </a:solidFill>
@@ -7223,7 +7223,7 @@
               <a:t>목적 2.  </a:t>
             </a:r>
             <a:r>
-              <a:rPr sz="2600" b="0">
+              <a:rPr sz="2200" b="0">
                 <a:solidFill>
                   <a:srgbClr val="2C2C2C"/>
                 </a:solidFill>
@@ -7311,8 +7311,8 @@
         </p:nvSpPr>
         <p:spPr>
           <a:xfrm>
-            <a:off x="1764000" y="24768000"/>
-            <a:ext cx="12420000" cy="6912000"/>
+            <a:off x="1764000" y="20340000"/>
+            <a:ext cx="12420000" cy="5688000"/>
           </a:xfrm>
           <a:prstGeom prst="rect">
             <a:avLst/>
@@ -7334,7 +7334,7 @@
               <a:defRPr/>
             </a:pPr>
             <a:r>
-              <a:rPr sz="2400" b="0">
+              <a:rPr sz="2200" b="0">
                 <a:solidFill>
                   <a:srgbClr val="2C2C2C"/>
                 </a:solidFill>
@@ -7352,7 +7352,7 @@
               </a:spcAft>
             </a:pPr>
             <a:r>
-              <a:rPr sz="2400" b="0">
+              <a:rPr sz="2200" b="0">
                 <a:solidFill>
                   <a:srgbClr val="2C2C2C"/>
                 </a:solidFill>
@@ -7379,8 +7379,8 @@
         </p:nvSpPr>
         <p:spPr>
           <a:xfrm>
-            <a:off x="1764000" y="33552000"/>
-            <a:ext cx="12420000" cy="2232000"/>
+            <a:off x="1764000" y="28008000"/>
+            <a:ext cx="12420000" cy="2016000"/>
           </a:xfrm>
           <a:prstGeom prst="rect">
             <a:avLst/>
@@ -7410,7 +7410,7 @@
                 <a:ea typeface="맑은 고딕"/>
                 <a:cs typeface="맑은 고딕"/>
               </a:rPr>
-              <a:t>자료는 X 공개 한국어 글에서 모았다(사용자명·외부 식별자 자동 비식별). 질의는 정밀·확장·맥락 점검·누적 확장의 네 층으로 설계했고, 회수 게시물은 2010년 9월~2026년 4월(약 15년 7개월)에 걸쳐 있다. 아래 LLM 보조 4층 정제 절차로 원자료를 좁혀 본문 코퍼스를 확정했다.</a:t>
+              <a:t>자료는 X 공개 한국어 글에서 모았다(사용자명·외부 식별자 자동 비식별). 질의는 정밀·확장·맥락 점검·누적 확장의 네 층으로 설계했고, 회수 게시물은 2010년 9월~2026년 4월(약 15년 7개월)에 걸쳐 있다.</a:t>
             </a:r>
           </a:p>
         </p:txBody>
@@ -7550,17 +7550,51 @@
         </p:blipFill>
         <p:spPr>
           <a:xfrm>
-            <a:off x="1728000" y="36000000"/>
-            <a:ext cx="6012000" cy="3526592"/>
+            <a:off x="1800000" y="30240000"/>
+            <a:ext cx="12240000" cy="4332448"/>
           </a:xfrm>
           <a:prstGeom prst="rect">
             <a:avLst/>
           </a:prstGeom>
         </p:spPr>
       </p:pic>
+      <p:sp>
+        <p:nvSpPr>
+          <p:cNvPr id="58" name="TextBox 57"/>
+          <p:cNvSpPr txBox="1"/>
+          <p:nvPr/>
+        </p:nvSpPr>
+        <p:spPr>
+          <a:xfrm>
+            <a:off x="1800000" y="34632000"/>
+            <a:ext cx="12240000" cy="504000"/>
+          </a:xfrm>
+          <a:prstGeom prst="rect">
+            <a:avLst/>
+          </a:prstGeom>
+          <a:noFill/>
+        </p:spPr>
+        <p:txBody>
+          <a:bodyPr wrap="square">
+            <a:spAutoFit/>
+          </a:bodyPr>
+          <a:lstStyle/>
+          <a:p>
+            <a:r>
+              <a:rPr sz="1400" i="1">
+                <a:solidFill>
+                  <a:srgbClr val="2C2C2C"/>
+                </a:solidFill>
+                <a:latin typeface="맑은 고딕"/>
+              </a:rPr>
+              <a:t>그림 1. LLM 보조 4층 정제 절차. 규칙 분류로 분량을 줄이고 경계 사례에만 LLM 판정(③)을 적용한다.</a:t>
+            </a:r>
+          </a:p>
+        </p:txBody>
+      </p:sp>
       <p:pic>
         <p:nvPicPr>
-          <p:cNvPr id="58" name="Picture 57" descr="corpus_funnel.png"/>
+          <p:cNvPr id="59" name="Picture 58" descr="corpus_funnel.png"/>
           <p:cNvPicPr>
             <a:picLocks noChangeAspect="1"/>
           </p:cNvPicPr>
@@ -7574,8 +7608,8 @@
         </p:blipFill>
         <p:spPr>
           <a:xfrm>
-            <a:off x="8028000" y="36432000"/>
-            <a:ext cx="6120000" cy="3418529"/>
+            <a:off x="3528000" y="35496000"/>
+            <a:ext cx="8568000" cy="4785940"/>
           </a:xfrm>
           <a:prstGeom prst="rect">
             <a:avLst/>
@@ -7584,48 +7618,14 @@
       </p:pic>
       <p:sp>
         <p:nvSpPr>
-          <p:cNvPr id="59" name="TextBox 58"/>
-          <p:cNvSpPr txBox="1"/>
-          <p:nvPr/>
-        </p:nvSpPr>
-        <p:spPr>
-          <a:xfrm>
-            <a:off x="1728000" y="39600000"/>
-            <a:ext cx="6012000" cy="504000"/>
-          </a:xfrm>
-          <a:prstGeom prst="rect">
-            <a:avLst/>
-          </a:prstGeom>
-          <a:noFill/>
-        </p:spPr>
-        <p:txBody>
-          <a:bodyPr wrap="square">
-            <a:spAutoFit/>
-          </a:bodyPr>
-          <a:lstStyle/>
-          <a:p>
-            <a:r>
-              <a:rPr sz="1400" i="1">
-                <a:solidFill>
-                  <a:srgbClr val="2C2C2C"/>
-                </a:solidFill>
-                <a:latin typeface="맑은 고딕"/>
-              </a:rPr>
-              <a:t>그림 1. LLM 보조 4층 정제 절차.</a:t>
-            </a:r>
-          </a:p>
-        </p:txBody>
-      </p:sp>
-      <p:sp>
-        <p:nvSpPr>
           <p:cNvPr id="60" name="TextBox 59"/>
           <p:cNvSpPr txBox="1"/>
           <p:nvPr/>
         </p:nvSpPr>
         <p:spPr>
           <a:xfrm>
-            <a:off x="8028000" y="39888000"/>
-            <a:ext cx="6120000" cy="504000"/>
+            <a:off x="3528000" y="40320000"/>
+            <a:ext cx="8568000" cy="504000"/>
           </a:xfrm>
           <a:prstGeom prst="rect">
             <a:avLst/>

</xml_diff>

<commit_message>
Tighten inter-section gaps; restyle comparison table
- Move left section bars up to where content actually ends (2.연구목표→390,
  II.이론배경→490, III.연구방법→705mm) and enlarge per-section fonts so each
  box fills with minimal whitespace; section-bar appearance unchanged.
- Restyle the comparison table: navy header row (white bold), zebra rows,
  bold row labels, roomier cells — both LaTeX (colortbl) and PPTX (explicit
  cell fills with the default table style removed).
- Mirror all changes in the PPTX deliverable; numbers verified intact.

Co-Authored-By: Claude Opus 4.8 <noreply@anthropic.com>
</commit_message>
<xml_diff>
--- a/kca/poster_kca_template.pptx
+++ b/kca/poster_kca_template.pptx
@@ -6655,7 +6655,7 @@
         </p:nvGrpSpPr>
         <p:grpSpPr>
           <a:xfrm>
-            <a:off x="1741743" y="15480000"/>
+            <a:off x="1741743" y="14040000"/>
             <a:ext cx="8398170" cy="698261"/>
             <a:chOff x="2075738" y="15366711"/>
             <a:chExt cx="8398170" cy="698261"/>
@@ -6767,7 +6767,7 @@
         </p:blipFill>
         <p:spPr>
           <a:xfrm>
-            <a:off x="1147126" y="18720000"/>
+            <a:off x="1147126" y="17640000"/>
             <a:ext cx="12780000" cy="1231000"/>
           </a:xfrm>
           <a:prstGeom prst="rect">
@@ -6789,7 +6789,7 @@
         </p:nvSpPr>
         <p:spPr>
           <a:xfrm>
-            <a:off x="1722700" y="18900000"/>
+            <a:off x="1722700" y="17820000"/>
             <a:ext cx="6106606" cy="888695"/>
           </a:xfrm>
           <a:prstGeom prst="rect">
@@ -6952,7 +6952,7 @@
         </p:blipFill>
         <p:spPr>
           <a:xfrm>
-            <a:off x="1278353" y="26280000"/>
+            <a:off x="1278353" y="25380000"/>
             <a:ext cx="12780000" cy="1242243"/>
           </a:xfrm>
           <a:prstGeom prst="rect">
@@ -6974,7 +6974,7 @@
         </p:nvSpPr>
         <p:spPr>
           <a:xfrm>
-            <a:off x="1786178" y="26388000"/>
+            <a:off x="1786178" y="25488000"/>
             <a:ext cx="7198431" cy="888695"/>
           </a:xfrm>
           <a:prstGeom prst="rect">
@@ -7111,7 +7111,7 @@
         <p:spPr>
           <a:xfrm>
             <a:off x="1872000" y="9000000"/>
-            <a:ext cx="12420000" cy="5760000"/>
+            <a:ext cx="12420000" cy="4968000"/>
           </a:xfrm>
           <a:prstGeom prst="rect">
             <a:avLst/>
@@ -7133,7 +7133,7 @@
               <a:defRPr/>
             </a:pPr>
             <a:r>
-              <a:rPr sz="2300" b="0">
+              <a:rPr sz="2500" b="0">
                 <a:solidFill>
                   <a:srgbClr val="2C2C2C"/>
                 </a:solidFill>
@@ -7160,8 +7160,8 @@
         </p:nvSpPr>
         <p:spPr>
           <a:xfrm>
-            <a:off x="1980000" y="16380000"/>
-            <a:ext cx="12420000" cy="2160000"/>
+            <a:off x="1980000" y="14868000"/>
+            <a:ext cx="12420000" cy="2592000"/>
           </a:xfrm>
           <a:prstGeom prst="rect">
             <a:avLst/>
@@ -7311,8 +7311,8 @@
         </p:nvSpPr>
         <p:spPr>
           <a:xfrm>
-            <a:off x="1764000" y="20340000"/>
-            <a:ext cx="12420000" cy="5688000"/>
+            <a:off x="1764000" y="19260000"/>
+            <a:ext cx="12420000" cy="6048000"/>
           </a:xfrm>
           <a:prstGeom prst="rect">
             <a:avLst/>
@@ -7334,7 +7334,7 @@
               <a:defRPr/>
             </a:pPr>
             <a:r>
-              <a:rPr sz="2200" b="0">
+              <a:rPr sz="2400" b="0">
                 <a:solidFill>
                   <a:srgbClr val="2C2C2C"/>
                 </a:solidFill>
@@ -7352,7 +7352,7 @@
               </a:spcAft>
             </a:pPr>
             <a:r>
-              <a:rPr sz="2200" b="0">
+              <a:rPr sz="2400" b="0">
                 <a:solidFill>
                   <a:srgbClr val="2C2C2C"/>
                 </a:solidFill>
@@ -7379,7 +7379,7 @@
         </p:nvSpPr>
         <p:spPr>
           <a:xfrm>
-            <a:off x="1764000" y="28008000"/>
+            <a:off x="1764000" y="27000000"/>
             <a:ext cx="12420000" cy="2016000"/>
           </a:xfrm>
           <a:prstGeom prst="rect">
@@ -7550,7 +7550,7 @@
         </p:blipFill>
         <p:spPr>
           <a:xfrm>
-            <a:off x="1800000" y="30240000"/>
+            <a:off x="1800000" y="29304000"/>
             <a:ext cx="12240000" cy="4332448"/>
           </a:xfrm>
           <a:prstGeom prst="rect">
@@ -7566,7 +7566,7 @@
         </p:nvSpPr>
         <p:spPr>
           <a:xfrm>
-            <a:off x="1800000" y="34632000"/>
+            <a:off x="1800000" y="33696000"/>
             <a:ext cx="12240000" cy="504000"/>
           </a:xfrm>
           <a:prstGeom prst="rect">
@@ -7608,7 +7608,7 @@
         </p:blipFill>
         <p:spPr>
           <a:xfrm>
-            <a:off x="3528000" y="35496000"/>
+            <a:off x="3528000" y="34560000"/>
             <a:ext cx="8568000" cy="4785940"/>
           </a:xfrm>
           <a:prstGeom prst="rect">
@@ -7624,7 +7624,7 @@
         </p:nvSpPr>
         <p:spPr>
           <a:xfrm>
-            <a:off x="3528000" y="40320000"/>
+            <a:off x="3528000" y="39384000"/>
             <a:ext cx="8568000" cy="504000"/>
           </a:xfrm>
           <a:prstGeom prst="rect">
@@ -7741,13 +7741,13 @@
         <a:graphic>
           <a:graphicData uri="http://schemas.openxmlformats.org/drawingml/2006/table">
             <a:tbl>
-              <a:tblPr firstRow="1" bandRow="1">
-                <a:tableStyleId>{5C22544A-7EE6-4342-B048-85BDC9FD1C3A}</a:tableStyleId>
+              <a:tblPr>
+                <a:tableStyleId>{2D5ABB26-0587-4C30-8999-92F81FD0307C}</a:tableStyleId>
               </a:tblPr>
               <a:tblGrid>
-                <a:gridCol w="1980000"/>
+                <a:gridCol w="2016000"/>
                 <a:gridCol w="5040000"/>
-                <a:gridCol w="4860000"/>
+                <a:gridCol w="4824000"/>
               </a:tblGrid>
               <a:tr h="691200">
                 <a:tc>
@@ -7768,7 +7768,11 @@
                       </a:r>
                     </a:p>
                   </a:txBody>
-                  <a:tcPr marL="72000" marR="72000" marT="36000" marB="36000" anchor="ctr"/>
+                  <a:tcPr marL="90000" marR="90000" marT="54000" marB="54000" anchor="ctr">
+                    <a:solidFill>
+                      <a:srgbClr val="14285A"/>
+                    </a:solidFill>
+                  </a:tcPr>
                 </a:tc>
                 <a:tc>
                   <a:txBody>
@@ -7788,7 +7792,11 @@
                       </a:r>
                     </a:p>
                   </a:txBody>
-                  <a:tcPr marL="72000" marR="72000" marT="36000" marB="36000" anchor="ctr"/>
+                  <a:tcPr marL="90000" marR="90000" marT="54000" marB="54000" anchor="ctr">
+                    <a:solidFill>
+                      <a:srgbClr val="14285A"/>
+                    </a:solidFill>
+                  </a:tcPr>
                 </a:tc>
                 <a:tc>
                   <a:txBody>
@@ -7808,7 +7816,11 @@
                       </a:r>
                     </a:p>
                   </a:txBody>
-                  <a:tcPr marL="72000" marR="72000" marT="36000" marB="36000" anchor="ctr"/>
+                  <a:tcPr marL="90000" marR="90000" marT="54000" marB="54000" anchor="ctr">
+                    <a:solidFill>
+                      <a:srgbClr val="14285A"/>
+                    </a:solidFill>
+                  </a:tcPr>
                 </a:tc>
               </a:tr>
               <a:tr h="691200">
@@ -7818,7 +7830,7 @@
                     <a:lstStyle/>
                     <a:p>
                       <a:r>
-                        <a:rPr sz="1700" b="0">
+                        <a:rPr sz="1700" b="1">
                           <a:solidFill>
                             <a:srgbClr val="2C2C2C"/>
                           </a:solidFill>
@@ -7830,7 +7842,11 @@
                       </a:r>
                     </a:p>
                   </a:txBody>
-                  <a:tcPr marL="72000" marR="72000" marT="36000" marB="36000" anchor="ctr"/>
+                  <a:tcPr marL="90000" marR="90000" marT="54000" marB="54000" anchor="ctr">
+                    <a:solidFill>
+                      <a:srgbClr val="ECEFF6"/>
+                    </a:solidFill>
+                  </a:tcPr>
                 </a:tc>
                 <a:tc>
                   <a:txBody>
@@ -7850,7 +7866,11 @@
                       </a:r>
                     </a:p>
                   </a:txBody>
-                  <a:tcPr marL="72000" marR="72000" marT="36000" marB="36000" anchor="ctr"/>
+                  <a:tcPr marL="90000" marR="90000" marT="54000" marB="54000" anchor="ctr">
+                    <a:solidFill>
+                      <a:srgbClr val="ECEFF6"/>
+                    </a:solidFill>
+                  </a:tcPr>
                 </a:tc>
                 <a:tc>
                   <a:txBody>
@@ -7870,7 +7890,11 @@
                       </a:r>
                     </a:p>
                   </a:txBody>
-                  <a:tcPr marL="72000" marR="72000" marT="36000" marB="36000" anchor="ctr"/>
+                  <a:tcPr marL="90000" marR="90000" marT="54000" marB="54000" anchor="ctr">
+                    <a:solidFill>
+                      <a:srgbClr val="ECEFF6"/>
+                    </a:solidFill>
+                  </a:tcPr>
                 </a:tc>
               </a:tr>
               <a:tr h="691200">
@@ -7880,7 +7904,7 @@
                     <a:lstStyle/>
                     <a:p>
                       <a:r>
-                        <a:rPr sz="1700" b="0">
+                        <a:rPr sz="1700" b="1">
                           <a:solidFill>
                             <a:srgbClr val="2C2C2C"/>
                           </a:solidFill>
@@ -7892,7 +7916,11 @@
                       </a:r>
                     </a:p>
                   </a:txBody>
-                  <a:tcPr marL="72000" marR="72000" marT="36000" marB="36000" anchor="ctr"/>
+                  <a:tcPr marL="90000" marR="90000" marT="54000" marB="54000" anchor="ctr">
+                    <a:solidFill>
+                      <a:srgbClr val="FFFFFF"/>
+                    </a:solidFill>
+                  </a:tcPr>
                 </a:tc>
                 <a:tc>
                   <a:txBody>
@@ -7912,7 +7940,11 @@
                       </a:r>
                     </a:p>
                   </a:txBody>
-                  <a:tcPr marL="72000" marR="72000" marT="36000" marB="36000" anchor="ctr"/>
+                  <a:tcPr marL="90000" marR="90000" marT="54000" marB="54000" anchor="ctr">
+                    <a:solidFill>
+                      <a:srgbClr val="FFFFFF"/>
+                    </a:solidFill>
+                  </a:tcPr>
                 </a:tc>
                 <a:tc>
                   <a:txBody>
@@ -7932,7 +7964,11 @@
                       </a:r>
                     </a:p>
                   </a:txBody>
-                  <a:tcPr marL="72000" marR="72000" marT="36000" marB="36000" anchor="ctr"/>
+                  <a:tcPr marL="90000" marR="90000" marT="54000" marB="54000" anchor="ctr">
+                    <a:solidFill>
+                      <a:srgbClr val="FFFFFF"/>
+                    </a:solidFill>
+                  </a:tcPr>
                 </a:tc>
               </a:tr>
               <a:tr h="691200">
@@ -7942,7 +7978,7 @@
                     <a:lstStyle/>
                     <a:p>
                       <a:r>
-                        <a:rPr sz="1700" b="0">
+                        <a:rPr sz="1700" b="1">
                           <a:solidFill>
                             <a:srgbClr val="2C2C2C"/>
                           </a:solidFill>
@@ -7954,7 +7990,11 @@
                       </a:r>
                     </a:p>
                   </a:txBody>
-                  <a:tcPr marL="72000" marR="72000" marT="36000" marB="36000" anchor="ctr"/>
+                  <a:tcPr marL="90000" marR="90000" marT="54000" marB="54000" anchor="ctr">
+                    <a:solidFill>
+                      <a:srgbClr val="ECEFF6"/>
+                    </a:solidFill>
+                  </a:tcPr>
                 </a:tc>
                 <a:tc>
                   <a:txBody>
@@ -7974,7 +8014,11 @@
                       </a:r>
                     </a:p>
                   </a:txBody>
-                  <a:tcPr marL="72000" marR="72000" marT="36000" marB="36000" anchor="ctr"/>
+                  <a:tcPr marL="90000" marR="90000" marT="54000" marB="54000" anchor="ctr">
+                    <a:solidFill>
+                      <a:srgbClr val="ECEFF6"/>
+                    </a:solidFill>
+                  </a:tcPr>
                 </a:tc>
                 <a:tc>
                   <a:txBody>
@@ -7994,7 +8038,11 @@
                       </a:r>
                     </a:p>
                   </a:txBody>
-                  <a:tcPr marL="72000" marR="72000" marT="36000" marB="36000" anchor="ctr"/>
+                  <a:tcPr marL="90000" marR="90000" marT="54000" marB="54000" anchor="ctr">
+                    <a:solidFill>
+                      <a:srgbClr val="ECEFF6"/>
+                    </a:solidFill>
+                  </a:tcPr>
                 </a:tc>
               </a:tr>
               <a:tr h="691200">
@@ -8004,7 +8052,7 @@
                     <a:lstStyle/>
                     <a:p>
                       <a:r>
-                        <a:rPr sz="1700" b="0">
+                        <a:rPr sz="1700" b="1">
                           <a:solidFill>
                             <a:srgbClr val="2C2C2C"/>
                           </a:solidFill>
@@ -8016,7 +8064,11 @@
                       </a:r>
                     </a:p>
                   </a:txBody>
-                  <a:tcPr marL="72000" marR="72000" marT="36000" marB="36000" anchor="ctr"/>
+                  <a:tcPr marL="90000" marR="90000" marT="54000" marB="54000" anchor="ctr">
+                    <a:solidFill>
+                      <a:srgbClr val="FFFFFF"/>
+                    </a:solidFill>
+                  </a:tcPr>
                 </a:tc>
                 <a:tc>
                   <a:txBody>
@@ -8036,7 +8088,11 @@
                       </a:r>
                     </a:p>
                   </a:txBody>
-                  <a:tcPr marL="72000" marR="72000" marT="36000" marB="36000" anchor="ctr"/>
+                  <a:tcPr marL="90000" marR="90000" marT="54000" marB="54000" anchor="ctr">
+                    <a:solidFill>
+                      <a:srgbClr val="FFFFFF"/>
+                    </a:solidFill>
+                  </a:tcPr>
                 </a:tc>
                 <a:tc>
                   <a:txBody>
@@ -8056,7 +8112,11 @@
                       </a:r>
                     </a:p>
                   </a:txBody>
-                  <a:tcPr marL="72000" marR="72000" marT="36000" marB="36000" anchor="ctr"/>
+                  <a:tcPr marL="90000" marR="90000" marT="54000" marB="54000" anchor="ctr">
+                    <a:solidFill>
+                      <a:srgbClr val="FFFFFF"/>
+                    </a:solidFill>
+                  </a:tcPr>
                 </a:tc>
               </a:tr>
             </a:tbl>

</xml_diff>

<commit_message>
Fix 서론/목표 overlap, center bar labels, narrow column gutter
- Fix the 서론 text overflowing onto the 2.연구목표 label: move the 목표
  subsection bar down (445mm) so the intro has room; re-fit fonts.
- Vertically center the section-bar labels (I~V): set them center-anchored
  to the bar height instead of top-anchored (they were sitting high).
- Narrow the center gutter: shift the left column +6mm and the right
  column -10mm toward center (bars, labels, and content).
- Apply identical transforms to the PPTX deliverable; numbers intact.

Co-Authored-By: Claude Opus 4.8 <noreply@anthropic.com>
</commit_message>
<xml_diff>
--- a/kca/poster_kca_template.pptx
+++ b/kca/poster_kca_template.pptx
@@ -6457,7 +6457,7 @@
         </p:blipFill>
         <p:spPr>
           <a:xfrm>
-            <a:off x="1210604" y="6474062"/>
+            <a:off x="1426604" y="6474062"/>
             <a:ext cx="12780000" cy="1236409"/>
           </a:xfrm>
           <a:prstGeom prst="rect">
@@ -6479,7 +6479,7 @@
         </p:nvGrpSpPr>
         <p:grpSpPr>
           <a:xfrm>
-            <a:off x="1583047" y="8174598"/>
+            <a:off x="1799047" y="8174598"/>
             <a:ext cx="8398170" cy="698261"/>
             <a:chOff x="1917042" y="6178257"/>
             <a:chExt cx="8398170" cy="698261"/>
@@ -6602,15 +6602,15 @@
         </p:nvSpPr>
         <p:spPr>
           <a:xfrm>
-            <a:off x="1684613" y="6660649"/>
-            <a:ext cx="2615303" cy="888695"/>
+            <a:off x="1900613" y="6472800"/>
+            <a:ext cx="2615303" cy="1234800"/>
           </a:xfrm>
           <a:prstGeom prst="rect">
             <a:avLst/>
           </a:prstGeom>
         </p:spPr>
         <p:txBody>
-          <a:bodyPr lIns="0" tIns="0" rIns="0" bIns="0" anchor="t"/>
+          <a:bodyPr lIns="0" tIns="0" rIns="0" bIns="0" anchor="ctr"/>
           <a:lstStyle/>
           <a:p>
             <a:pPr lvl="0" algn="l">
@@ -6655,7 +6655,7 @@
         </p:nvGrpSpPr>
         <p:grpSpPr>
           <a:xfrm>
-            <a:off x="1741743" y="14040000"/>
+            <a:off x="1957743" y="16020000"/>
             <a:ext cx="8398170" cy="698261"/>
             <a:chOff x="2075738" y="15366711"/>
             <a:chExt cx="8398170" cy="698261"/>
@@ -6767,7 +6767,7 @@
         </p:blipFill>
         <p:spPr>
           <a:xfrm>
-            <a:off x="1147126" y="17640000"/>
+            <a:off x="1363126" y="20340000"/>
             <a:ext cx="12780000" cy="1231000"/>
           </a:xfrm>
           <a:prstGeom prst="rect">
@@ -6789,15 +6789,15 @@
         </p:nvSpPr>
         <p:spPr>
           <a:xfrm>
-            <a:off x="1722700" y="17820000"/>
-            <a:ext cx="6106606" cy="888695"/>
+            <a:off x="1938700" y="20340000"/>
+            <a:ext cx="6106606" cy="1234800"/>
           </a:xfrm>
           <a:prstGeom prst="rect">
             <a:avLst/>
           </a:prstGeom>
         </p:spPr>
         <p:txBody>
-          <a:bodyPr lIns="0" tIns="0" rIns="0" bIns="0" anchor="t"/>
+          <a:bodyPr lIns="0" tIns="0" rIns="0" bIns="0" anchor="ctr"/>
           <a:lstStyle/>
           <a:p>
             <a:pPr lvl="0" algn="l">
@@ -6869,7 +6869,7 @@
         </p:blipFill>
         <p:spPr>
           <a:xfrm>
-            <a:off x="16064508" y="6474064"/>
+            <a:off x="15704508" y="6474064"/>
             <a:ext cx="12780000" cy="1231000"/>
           </a:xfrm>
           <a:prstGeom prst="rect">
@@ -6952,7 +6952,7 @@
         </p:blipFill>
         <p:spPr>
           <a:xfrm>
-            <a:off x="1278353" y="25380000"/>
+            <a:off x="1494353" y="27360000"/>
             <a:ext cx="12780000" cy="1242243"/>
           </a:xfrm>
           <a:prstGeom prst="rect">
@@ -6974,15 +6974,15 @@
         </p:nvSpPr>
         <p:spPr>
           <a:xfrm>
-            <a:off x="1786178" y="25488000"/>
-            <a:ext cx="7198431" cy="888695"/>
+            <a:off x="2002178" y="27360000"/>
+            <a:ext cx="7198431" cy="1234800"/>
           </a:xfrm>
           <a:prstGeom prst="rect">
             <a:avLst/>
           </a:prstGeom>
         </p:spPr>
         <p:txBody>
-          <a:bodyPr lIns="0" tIns="0" rIns="0" bIns="0" anchor="t"/>
+          <a:bodyPr lIns="0" tIns="0" rIns="0" bIns="0" anchor="ctr"/>
           <a:lstStyle/>
           <a:p>
             <a:pPr lvl="0" algn="l">
@@ -7035,7 +7035,7 @@
         </p:blipFill>
         <p:spPr>
           <a:xfrm>
-            <a:off x="16064508" y="31992309"/>
+            <a:off x="15704508" y="31992309"/>
             <a:ext cx="12780000" cy="1225273"/>
           </a:xfrm>
           <a:prstGeom prst="rect">
@@ -7057,15 +7057,15 @@
         </p:nvSpPr>
         <p:spPr>
           <a:xfrm>
-            <a:off x="16640083" y="32121747"/>
-            <a:ext cx="4976693" cy="888695"/>
+            <a:off x="16280083" y="31993200"/>
+            <a:ext cx="4976693" cy="1234800"/>
           </a:xfrm>
           <a:prstGeom prst="rect">
             <a:avLst/>
           </a:prstGeom>
         </p:spPr>
         <p:txBody>
-          <a:bodyPr lIns="0" tIns="0" rIns="0" bIns="0" anchor="t"/>
+          <a:bodyPr lIns="0" tIns="0" rIns="0" bIns="0" anchor="ctr"/>
           <a:lstStyle/>
           <a:p>
             <a:pPr lvl="0" algn="l">
@@ -7110,8 +7110,8 @@
         </p:nvSpPr>
         <p:spPr>
           <a:xfrm>
-            <a:off x="1872000" y="9000000"/>
-            <a:ext cx="12420000" cy="4968000"/>
+            <a:off x="2088000" y="9000000"/>
+            <a:ext cx="12420000" cy="6840000"/>
           </a:xfrm>
           <a:prstGeom prst="rect">
             <a:avLst/>
@@ -7133,7 +7133,7 @@
               <a:defRPr/>
             </a:pPr>
             <a:r>
-              <a:rPr sz="2500" b="0">
+              <a:rPr sz="2700" b="0">
                 <a:solidFill>
                   <a:srgbClr val="2C2C2C"/>
                 </a:solidFill>
@@ -7160,8 +7160,8 @@
         </p:nvSpPr>
         <p:spPr>
           <a:xfrm>
-            <a:off x="1980000" y="14868000"/>
-            <a:ext cx="12420000" cy="2592000"/>
+            <a:off x="2196000" y="16920000"/>
+            <a:ext cx="12420000" cy="3240000"/>
           </a:xfrm>
           <a:prstGeom prst="rect">
             <a:avLst/>
@@ -7250,8 +7250,8 @@
         </p:nvSpPr>
         <p:spPr>
           <a:xfrm>
-            <a:off x="16524000" y="8064000"/>
-            <a:ext cx="11880000" cy="2376000"/>
+            <a:off x="16164000" y="8064000"/>
+            <a:ext cx="12168000" cy="2376000"/>
           </a:xfrm>
           <a:prstGeom prst="rect">
             <a:avLst/>
@@ -7311,8 +7311,8 @@
         </p:nvSpPr>
         <p:spPr>
           <a:xfrm>
-            <a:off x="1764000" y="19260000"/>
-            <a:ext cx="12420000" cy="6048000"/>
+            <a:off x="1980000" y="21960000"/>
+            <a:ext cx="12420000" cy="5220000"/>
           </a:xfrm>
           <a:prstGeom prst="rect">
             <a:avLst/>
@@ -7334,7 +7334,7 @@
               <a:defRPr/>
             </a:pPr>
             <a:r>
-              <a:rPr sz="2400" b="0">
+              <a:rPr sz="2300" b="0">
                 <a:solidFill>
                   <a:srgbClr val="2C2C2C"/>
                 </a:solidFill>
@@ -7352,7 +7352,7 @@
               </a:spcAft>
             </a:pPr>
             <a:r>
-              <a:rPr sz="2400" b="0">
+              <a:rPr sz="2300" b="0">
                 <a:solidFill>
                   <a:srgbClr val="2C2C2C"/>
                 </a:solidFill>
@@ -7379,8 +7379,8 @@
         </p:nvSpPr>
         <p:spPr>
           <a:xfrm>
-            <a:off x="1764000" y="27000000"/>
-            <a:ext cx="12420000" cy="2016000"/>
+            <a:off x="1980000" y="28980000"/>
+            <a:ext cx="12420000" cy="1800000"/>
           </a:xfrm>
           <a:prstGeom prst="rect">
             <a:avLst/>
@@ -7429,8 +7429,8 @@
         </p:nvSpPr>
         <p:spPr>
           <a:xfrm>
-            <a:off x="16524000" y="33696000"/>
-            <a:ext cx="11880000" cy="7200000"/>
+            <a:off x="16164000" y="33696000"/>
+            <a:ext cx="12168000" cy="7200000"/>
           </a:xfrm>
           <a:prstGeom prst="rect">
             <a:avLst/>
@@ -7550,8 +7550,8 @@
         </p:blipFill>
         <p:spPr>
           <a:xfrm>
-            <a:off x="1800000" y="29304000"/>
-            <a:ext cx="12240000" cy="4332448"/>
+            <a:off x="2016000" y="30816000"/>
+            <a:ext cx="12168000" cy="4306963"/>
           </a:xfrm>
           <a:prstGeom prst="rect">
             <a:avLst/>
@@ -7566,8 +7566,8 @@
         </p:nvSpPr>
         <p:spPr>
           <a:xfrm>
-            <a:off x="1800000" y="33696000"/>
-            <a:ext cx="12240000" cy="504000"/>
+            <a:off x="2016000" y="35208000"/>
+            <a:ext cx="12168000" cy="504000"/>
           </a:xfrm>
           <a:prstGeom prst="rect">
             <a:avLst/>
@@ -7608,8 +7608,8 @@
         </p:blipFill>
         <p:spPr>
           <a:xfrm>
-            <a:off x="3528000" y="34560000"/>
-            <a:ext cx="8568000" cy="4785940"/>
+            <a:off x="4248000" y="36072000"/>
+            <a:ext cx="7380000" cy="4122343"/>
           </a:xfrm>
           <a:prstGeom prst="rect">
             <a:avLst/>
@@ -7624,8 +7624,8 @@
         </p:nvSpPr>
         <p:spPr>
           <a:xfrm>
-            <a:off x="3528000" y="39384000"/>
-            <a:ext cx="8568000" cy="504000"/>
+            <a:off x="4248000" y="40248000"/>
+            <a:ext cx="7380000" cy="504000"/>
           </a:xfrm>
           <a:prstGeom prst="rect">
             <a:avLst/>
@@ -7666,8 +7666,8 @@
         </p:blipFill>
         <p:spPr>
           <a:xfrm>
-            <a:off x="16668000" y="10512000"/>
-            <a:ext cx="11592000" cy="4327680"/>
+            <a:off x="16308000" y="10440000"/>
+            <a:ext cx="11880000" cy="4435200"/>
           </a:xfrm>
           <a:prstGeom prst="rect">
             <a:avLst/>
@@ -7682,8 +7682,8 @@
         </p:nvSpPr>
         <p:spPr>
           <a:xfrm>
-            <a:off x="16524000" y="15120000"/>
-            <a:ext cx="11880000" cy="1872000"/>
+            <a:off x="16164000" y="15120000"/>
+            <a:ext cx="12168000" cy="1872000"/>
           </a:xfrm>
           <a:prstGeom prst="rect">
             <a:avLst/>
@@ -7735,8 +7735,8 @@
           <p:nvPr/>
         </p:nvGraphicFramePr>
         <p:xfrm>
-          <a:off x="16524000" y="17208000"/>
-          <a:ext cx="11880000" cy="3456000"/>
+          <a:off x="16164000" y="17208000"/>
+          <a:ext cx="12168000" cy="3456000"/>
         </p:xfrm>
         <a:graphic>
           <a:graphicData uri="http://schemas.openxmlformats.org/drawingml/2006/table">
@@ -7745,9 +7745,9 @@
                 <a:tableStyleId>{2D5ABB26-0587-4C30-8999-92F81FD0307C}</a:tableStyleId>
               </a:tblPr>
               <a:tblGrid>
-                <a:gridCol w="2016000"/>
-                <a:gridCol w="5040000"/>
-                <a:gridCol w="4824000"/>
+                <a:gridCol w="2088000"/>
+                <a:gridCol w="5112000"/>
+                <a:gridCol w="4968000"/>
               </a:tblGrid>
               <a:tr h="691200">
                 <a:tc>
@@ -8131,8 +8131,8 @@
         </p:nvSpPr>
         <p:spPr>
           <a:xfrm>
-            <a:off x="16524000" y="20952000"/>
-            <a:ext cx="11880000" cy="2880000"/>
+            <a:off x="16164000" y="20952000"/>
+            <a:ext cx="12168000" cy="2880000"/>
           </a:xfrm>
           <a:prstGeom prst="rect">
             <a:avLst/>
@@ -8191,8 +8191,8 @@
         </p:blipFill>
         <p:spPr>
           <a:xfrm>
-            <a:off x="16920000" y="24192000"/>
-            <a:ext cx="10800000" cy="5597468"/>
+            <a:off x="16560000" y="24192000"/>
+            <a:ext cx="10980000" cy="5690759"/>
           </a:xfrm>
           <a:prstGeom prst="rect">
             <a:avLst/>

</xml_diff>

<commit_message>
Unify typography/spacing across sections; polish Korean phrasing
- Verified PPTX and LaTeX match (bars, blocks, figures, table); remaining
  visual diff is only LibreOffice font substitution (PPTX uses 맑은 고딕,
  correct in PowerPoint).
- Uniform typography: body 28/38pt everywhere (was 26-31 mixed), subheads
  30pt with consistent before/after spacing, captions 18pt italic in
  softened gray; heading-to-body gap standardized (~14mm below each bar).
- Even section gaps: bars at 440/545/755; method content reflowed so the
  funnel caption sits inside the white panel (funnel 182mm, tighter
  pipeline node spacing).
- 윤문: break the triple repetition of "갈렸다" (나뉘었다 / 서로
  구분되었으며 / 갈렸다 once); applied to both LaTeX and PPTX.
- PPTX synced: same bar positions, content boxes, uniform 23pt body,
  wider one-line section labels; all numbers verified intact.

Co-Authored-By: Claude Opus 4.8 <noreply@anthropic.com>
</commit_message>
<xml_diff>
--- a/kca/poster_kca_template.pptx
+++ b/kca/poster_kca_template.pptx
@@ -6603,14 +6603,14 @@
         <p:spPr>
           <a:xfrm>
             <a:off x="1900613" y="6472800"/>
-            <a:ext cx="2615303" cy="1234800"/>
+            <a:ext cx="4055303" cy="1234800"/>
           </a:xfrm>
           <a:prstGeom prst="rect">
             <a:avLst/>
           </a:prstGeom>
         </p:spPr>
         <p:txBody>
-          <a:bodyPr lIns="0" tIns="0" rIns="0" bIns="0" anchor="ctr"/>
+          <a:bodyPr lIns="0" tIns="0" rIns="0" bIns="0" anchor="ctr" wrap="none"/>
           <a:lstStyle/>
           <a:p>
             <a:pPr lvl="0" algn="l">
@@ -6655,7 +6655,7 @@
         </p:nvGrpSpPr>
         <p:grpSpPr>
           <a:xfrm>
-            <a:off x="1957743" y="16020000"/>
+            <a:off x="1957743" y="15840000"/>
             <a:ext cx="8398170" cy="698261"/>
             <a:chOff x="2075738" y="15366711"/>
             <a:chExt cx="8398170" cy="698261"/>
@@ -6767,7 +6767,7 @@
         </p:blipFill>
         <p:spPr>
           <a:xfrm>
-            <a:off x="1363126" y="20340000"/>
+            <a:off x="1363126" y="19620000"/>
             <a:ext cx="12780000" cy="1231000"/>
           </a:xfrm>
           <a:prstGeom prst="rect">
@@ -6789,15 +6789,15 @@
         </p:nvSpPr>
         <p:spPr>
           <a:xfrm>
-            <a:off x="1938700" y="20340000"/>
-            <a:ext cx="6106606" cy="1234800"/>
+            <a:off x="1938700" y="19620000"/>
+            <a:ext cx="7546606" cy="1234800"/>
           </a:xfrm>
           <a:prstGeom prst="rect">
             <a:avLst/>
           </a:prstGeom>
         </p:spPr>
         <p:txBody>
-          <a:bodyPr lIns="0" tIns="0" rIns="0" bIns="0" anchor="ctr"/>
+          <a:bodyPr lIns="0" tIns="0" rIns="0" bIns="0" anchor="ctr" wrap="none"/>
           <a:lstStyle/>
           <a:p>
             <a:pPr lvl="0" algn="l">
@@ -6952,7 +6952,7 @@
         </p:blipFill>
         <p:spPr>
           <a:xfrm>
-            <a:off x="1494353" y="27360000"/>
+            <a:off x="1494353" y="27180000"/>
             <a:ext cx="12780000" cy="1242243"/>
           </a:xfrm>
           <a:prstGeom prst="rect">
@@ -6974,15 +6974,15 @@
         </p:nvSpPr>
         <p:spPr>
           <a:xfrm>
-            <a:off x="2002178" y="27360000"/>
-            <a:ext cx="7198431" cy="1234800"/>
+            <a:off x="2002178" y="27180000"/>
+            <a:ext cx="8638431" cy="1234800"/>
           </a:xfrm>
           <a:prstGeom prst="rect">
             <a:avLst/>
           </a:prstGeom>
         </p:spPr>
         <p:txBody>
-          <a:bodyPr lIns="0" tIns="0" rIns="0" bIns="0" anchor="ctr"/>
+          <a:bodyPr lIns="0" tIns="0" rIns="0" bIns="0" anchor="ctr" wrap="none"/>
           <a:lstStyle/>
           <a:p>
             <a:pPr lvl="0" algn="l">
@@ -7058,14 +7058,14 @@
         <p:spPr>
           <a:xfrm>
             <a:off x="16280083" y="31993200"/>
-            <a:ext cx="4976693" cy="1234800"/>
+            <a:ext cx="6416693" cy="1234800"/>
           </a:xfrm>
           <a:prstGeom prst="rect">
             <a:avLst/>
           </a:prstGeom>
         </p:spPr>
         <p:txBody>
-          <a:bodyPr lIns="0" tIns="0" rIns="0" bIns="0" anchor="ctr"/>
+          <a:bodyPr lIns="0" tIns="0" rIns="0" bIns="0" anchor="ctr" wrap="none"/>
           <a:lstStyle/>
           <a:p>
             <a:pPr lvl="0" algn="l">
@@ -7110,8 +7110,8 @@
         </p:nvSpPr>
         <p:spPr>
           <a:xfrm>
-            <a:off x="2088000" y="9000000"/>
-            <a:ext cx="12420000" cy="6840000"/>
+            <a:off x="2088000" y="9072000"/>
+            <a:ext cx="12420000" cy="6480000"/>
           </a:xfrm>
           <a:prstGeom prst="rect">
             <a:avLst/>
@@ -7133,7 +7133,7 @@
               <a:defRPr/>
             </a:pPr>
             <a:r>
-              <a:rPr sz="2700" b="0">
+              <a:rPr sz="2300" b="0">
                 <a:solidFill>
                   <a:srgbClr val="2C2C2C"/>
                 </a:solidFill>
@@ -7160,8 +7160,8 @@
         </p:nvSpPr>
         <p:spPr>
           <a:xfrm>
-            <a:off x="2196000" y="16920000"/>
-            <a:ext cx="12420000" cy="3240000"/>
+            <a:off x="2196000" y="16812000"/>
+            <a:ext cx="12420000" cy="2520000"/>
           </a:xfrm>
           <a:prstGeom prst="rect">
             <a:avLst/>
@@ -7183,7 +7183,7 @@
               <a:defRPr/>
             </a:pPr>
             <a:r>
-              <a:rPr sz="2200" b="1">
+              <a:rPr sz="2300" b="1">
                 <a:solidFill>
                   <a:srgbClr val="2C2C2C"/>
                 </a:solidFill>
@@ -7194,7 +7194,7 @@
               <a:t>목적 1.  </a:t>
             </a:r>
             <a:r>
-              <a:rPr sz="2200" b="0">
+              <a:rPr sz="2300" b="0">
                 <a:solidFill>
                   <a:srgbClr val="2C2C2C"/>
                 </a:solidFill>
@@ -7212,7 +7212,7 @@
               </a:spcAft>
             </a:pPr>
             <a:r>
-              <a:rPr sz="2200" b="1">
+              <a:rPr sz="2300" b="1">
                 <a:solidFill>
                   <a:srgbClr val="2C2C2C"/>
                 </a:solidFill>
@@ -7223,7 +7223,7 @@
               <a:t>목적 2.  </a:t>
             </a:r>
             <a:r>
-              <a:rPr sz="2200" b="0">
+              <a:rPr sz="2300" b="0">
                 <a:solidFill>
                   <a:srgbClr val="2C2C2C"/>
                 </a:solidFill>
@@ -7273,7 +7273,7 @@
               <a:defRPr/>
             </a:pPr>
             <a:r>
-              <a:rPr sz="2400" b="1">
+              <a:rPr sz="2300" b="1">
                 <a:solidFill>
                   <a:srgbClr val="2C2C2C"/>
                 </a:solidFill>
@@ -7284,7 +7284,7 @@
               <a:t>기초 분포 — </a:t>
             </a:r>
             <a:r>
-              <a:rPr sz="2400" b="0">
+              <a:rPr sz="2300" b="0">
                 <a:solidFill>
                   <a:srgbClr val="2C2C2C"/>
                 </a:solidFill>
@@ -7292,7 +7292,7 @@
                 <a:ea typeface="맑은 고딕"/>
                 <a:cs typeface="맑은 고딕"/>
               </a:rPr>
-              <a:t>본문 코퍼스 361건의 경험 극성은 부정 117·혼합 91·긍정 126·중립 27건이다. 정식 표본에서 과소표집되던 부정 경험이 긍정과 엇비슷한 규모로 함께 들어왔다. 장면은 일반 정신건강 상담 268건과 청소년 학교상담 93건(약 26%)으로 갈렸다.</a:t>
+              <a:t>본문 코퍼스 361건의 경험 극성은 부정 117·혼합 91·긍정 126·중립 27건이다. 정식 표본에서 과소표집되던 부정 경험이 긍정과 엇비슷한 규모로 함께 들어왔다. 장면은 일반 정신건강 상담 268건과 청소년 학교상담 93건(약 26%)으로 나뉘었다.</a:t>
             </a:r>
           </a:p>
         </p:txBody>
@@ -7311,8 +7311,8 @@
         </p:nvSpPr>
         <p:spPr>
           <a:xfrm>
-            <a:off x="1980000" y="21960000"/>
-            <a:ext cx="12420000" cy="5220000"/>
+            <a:off x="1980000" y="21348000"/>
+            <a:ext cx="12420000" cy="5400000"/>
           </a:xfrm>
           <a:prstGeom prst="rect">
             <a:avLst/>
@@ -7379,8 +7379,8 @@
         </p:nvSpPr>
         <p:spPr>
           <a:xfrm>
-            <a:off x="1980000" y="28980000"/>
-            <a:ext cx="12420000" cy="1800000"/>
+            <a:off x="1980000" y="28908000"/>
+            <a:ext cx="12420000" cy="1620000"/>
           </a:xfrm>
           <a:prstGeom prst="rect">
             <a:avLst/>
@@ -7452,7 +7452,7 @@
               <a:defRPr/>
             </a:pPr>
             <a:r>
-              <a:rPr sz="2400" b="1">
+              <a:rPr sz="2300" b="1">
                 <a:solidFill>
                   <a:srgbClr val="2C2C2C"/>
                 </a:solidFill>
@@ -7463,7 +7463,7 @@
               <a:t>함의:  </a:t>
             </a:r>
             <a:r>
-              <a:rPr sz="2400" b="0">
+              <a:rPr sz="2300" b="0">
                 <a:solidFill>
                   <a:srgbClr val="2C2C2C"/>
                 </a:solidFill>
@@ -7471,7 +7471,7 @@
                 <a:ea typeface="맑은 고딕"/>
                 <a:cs typeface="맑은 고딕"/>
               </a:rPr>
-              <a:t>정식 표본에서 좀처럼 함께 모이지 않던 부정과 긍정 경험이 익명 환경에서는 거의 같은 비중으로 함께 기록되었다(부정 117·긍정 126건). 사건 단위의 경험 언어도 분포 수준에서 갈렸으며, 그 표지는 면접 자료를 분석한 문보경·장성숙(2001)과 닮았다. 다만 이 일치는 같은 모집단의 일치가 아니라, 본 연구의 코드가 그 표지를 출발점으로 삼은 데서 비롯한다.</a:t>
+              <a:t>정식 표본에서 좀처럼 함께 모이지 않던 부정과 긍정 경험이 익명 환경에서는 거의 같은 비중으로 함께 기록되었다(부정 117·긍정 126건). 사건 단위의 경험 언어도 분포 수준에서 서로 구분되었으며, 그 표지는 면접 자료를 분석한 문보경·장성숙(2001)과 닮았다. 다만 이 일치는 같은 모집단의 일치가 아니라, 본 연구의 코드가 그 표지를 출발점으로 삼은 데서 비롯한다.</a:t>
             </a:r>
           </a:p>
           <a:p>
@@ -7481,7 +7481,7 @@
               </a:spcAft>
             </a:pPr>
             <a:r>
-              <a:rPr sz="2400" b="1">
+              <a:rPr sz="2300" b="1">
                 <a:solidFill>
                   <a:srgbClr val="2C2C2C"/>
                 </a:solidFill>
@@ -7492,7 +7492,7 @@
               <a:t>한계:  </a:t>
             </a:r>
             <a:r>
-              <a:rPr sz="2400" b="0">
+              <a:rPr sz="2300" b="0">
                 <a:solidFill>
                   <a:srgbClr val="2C2C2C"/>
                 </a:solidFill>
@@ -7510,7 +7510,7 @@
               </a:spcAft>
             </a:pPr>
             <a:r>
-              <a:rPr sz="2400" b="1">
+              <a:rPr sz="2300" b="1">
                 <a:solidFill>
                   <a:srgbClr val="2C2C2C"/>
                 </a:solidFill>
@@ -7521,7 +7521,7 @@
               <a:t>전망:  </a:t>
             </a:r>
             <a:r>
-              <a:rPr sz="2400" b="0">
+              <a:rPr sz="2300" b="0">
                 <a:solidFill>
                   <a:srgbClr val="2C2C2C"/>
                 </a:solidFill>
@@ -7550,7 +7550,7 @@
         </p:blipFill>
         <p:spPr>
           <a:xfrm>
-            <a:off x="2016000" y="30816000"/>
+            <a:off x="2016000" y="30672000"/>
             <a:ext cx="12168000" cy="4306963"/>
           </a:xfrm>
           <a:prstGeom prst="rect">
@@ -7566,7 +7566,7 @@
         </p:nvSpPr>
         <p:spPr>
           <a:xfrm>
-            <a:off x="2016000" y="35208000"/>
+            <a:off x="2016000" y="34992000"/>
             <a:ext cx="12168000" cy="504000"/>
           </a:xfrm>
           <a:prstGeom prst="rect">
@@ -7608,8 +7608,8 @@
         </p:blipFill>
         <p:spPr>
           <a:xfrm>
-            <a:off x="4248000" y="36072000"/>
-            <a:ext cx="7380000" cy="4122343"/>
+            <a:off x="4608000" y="35640000"/>
+            <a:ext cx="6552000" cy="3659837"/>
           </a:xfrm>
           <a:prstGeom prst="rect">
             <a:avLst/>
@@ -7624,8 +7624,8 @@
         </p:nvSpPr>
         <p:spPr>
           <a:xfrm>
-            <a:off x="4248000" y="40248000"/>
-            <a:ext cx="7380000" cy="504000"/>
+            <a:off x="4608000" y="39420000"/>
+            <a:ext cx="6552000" cy="504000"/>
           </a:xfrm>
           <a:prstGeom prst="rect">
             <a:avLst/>
@@ -7702,7 +7702,7 @@
               </a:spcAft>
             </a:pPr>
             <a:r>
-              <a:rPr sz="2400" b="1">
+              <a:rPr sz="2300" b="1">
                 <a:solidFill>
                   <a:srgbClr val="2C2C2C"/>
                 </a:solidFill>
@@ -7713,7 +7713,7 @@
               <a:t>면접 기반 선행 연구와의 비교 — </a:t>
             </a:r>
             <a:r>
-              <a:rPr sz="2400" b="0">
+              <a:rPr sz="2300" b="0">
                 <a:solidFill>
                   <a:srgbClr val="2C2C2C"/>
                 </a:solidFill>
@@ -8151,7 +8151,7 @@
               </a:spcAft>
             </a:pPr>
             <a:r>
-              <a:rPr sz="2400" b="1">
+              <a:rPr sz="2300" b="1">
                 <a:solidFill>
                   <a:srgbClr val="2C2C2C"/>
                 </a:solidFill>
@@ -8162,7 +8162,7 @@
               <a:t>과정 코드의 극성별 대비 — </a:t>
             </a:r>
             <a:r>
-              <a:rPr sz="2400" b="0">
+              <a:rPr sz="2300" b="0">
                 <a:solidFill>
                   <a:srgbClr val="2C2C2C"/>
                 </a:solidFill>

</xml_diff>

<commit_message>
Pack the poster: larger fonts/figures, even gaps, centered bar labels
Per feedback that whitespace grew and spacing was inconsistent:
- Enlarge body to 30pt (left column; results 29pt) and figures (funnel
  188mm, pipeline 315mm-wide nodes at 21/19pt, captions 19pt) so each
  section fills its box — poster reads dense, not airy.
- Standardize label-to-body and bar-to-body gaps (~10mm below bars,
  ~4mm below subsection labels), especially in 서론.
- Fix bar-label vertical centering for real: LibreOffice renders Korean
  glyphs low under center-anchor, so nudge label boxes -5.5mm for optical
  centering (I~V all verified).
- Re-place bars at 452/550/777 to match the larger content; fix 그림 4
  caption colliding with the V bar; keep all captions inside the panel.
- Mirror everything in the PPTX (24pt body, same geometry); numbers intact.

Co-Authored-By: Claude Opus 4.8 <noreply@anthropic.com>
</commit_message>
<xml_diff>
--- a/kca/poster_kca_template.pptx
+++ b/kca/poster_kca_template.pptx
@@ -6602,7 +6602,7 @@
         </p:nvSpPr>
         <p:spPr>
           <a:xfrm>
-            <a:off x="1900613" y="6472800"/>
+            <a:off x="1900613" y="6274800"/>
             <a:ext cx="4055303" cy="1234800"/>
           </a:xfrm>
           <a:prstGeom prst="rect">
@@ -6655,7 +6655,7 @@
         </p:nvGrpSpPr>
         <p:grpSpPr>
           <a:xfrm>
-            <a:off x="1957743" y="15840000"/>
+            <a:off x="1957743" y="16272000"/>
             <a:ext cx="8398170" cy="698261"/>
             <a:chOff x="2075738" y="15366711"/>
             <a:chExt cx="8398170" cy="698261"/>
@@ -6767,7 +6767,7 @@
         </p:blipFill>
         <p:spPr>
           <a:xfrm>
-            <a:off x="1363126" y="19620000"/>
+            <a:off x="1363126" y="19800000"/>
             <a:ext cx="12780000" cy="1231000"/>
           </a:xfrm>
           <a:prstGeom prst="rect">
@@ -6789,7 +6789,7 @@
         </p:nvSpPr>
         <p:spPr>
           <a:xfrm>
-            <a:off x="1938700" y="19620000"/>
+            <a:off x="1938700" y="19602000"/>
             <a:ext cx="7546606" cy="1234800"/>
           </a:xfrm>
           <a:prstGeom prst="rect">
@@ -6952,7 +6952,7 @@
         </p:blipFill>
         <p:spPr>
           <a:xfrm>
-            <a:off x="1494353" y="27180000"/>
+            <a:off x="1494353" y="27972000"/>
             <a:ext cx="12780000" cy="1242243"/>
           </a:xfrm>
           <a:prstGeom prst="rect">
@@ -6974,7 +6974,7 @@
         </p:nvSpPr>
         <p:spPr>
           <a:xfrm>
-            <a:off x="2002178" y="27180000"/>
+            <a:off x="2002178" y="27774000"/>
             <a:ext cx="8638431" cy="1234800"/>
           </a:xfrm>
           <a:prstGeom prst="rect">
@@ -7057,7 +7057,7 @@
         </p:nvSpPr>
         <p:spPr>
           <a:xfrm>
-            <a:off x="16280083" y="31993200"/>
+            <a:off x="16280083" y="31795200"/>
             <a:ext cx="6416693" cy="1234800"/>
           </a:xfrm>
           <a:prstGeom prst="rect">
@@ -7110,8 +7110,8 @@
         </p:nvSpPr>
         <p:spPr>
           <a:xfrm>
-            <a:off x="2088000" y="9072000"/>
-            <a:ext cx="12420000" cy="6480000"/>
+            <a:off x="2088000" y="9000000"/>
+            <a:ext cx="12420000" cy="7020000"/>
           </a:xfrm>
           <a:prstGeom prst="rect">
             <a:avLst/>
@@ -7133,7 +7133,7 @@
               <a:defRPr/>
             </a:pPr>
             <a:r>
-              <a:rPr sz="2300" b="0">
+              <a:rPr sz="2400" b="0">
                 <a:solidFill>
                   <a:srgbClr val="2C2C2C"/>
                 </a:solidFill>
@@ -7160,8 +7160,8 @@
         </p:nvSpPr>
         <p:spPr>
           <a:xfrm>
-            <a:off x="2196000" y="16812000"/>
-            <a:ext cx="12420000" cy="2520000"/>
+            <a:off x="2196000" y="17208000"/>
+            <a:ext cx="12420000" cy="2340000"/>
           </a:xfrm>
           <a:prstGeom prst="rect">
             <a:avLst/>
@@ -7183,7 +7183,7 @@
               <a:defRPr/>
             </a:pPr>
             <a:r>
-              <a:rPr sz="2300" b="1">
+              <a:rPr sz="2400" b="1">
                 <a:solidFill>
                   <a:srgbClr val="2C2C2C"/>
                 </a:solidFill>
@@ -7194,7 +7194,7 @@
               <a:t>목적 1.  </a:t>
             </a:r>
             <a:r>
-              <a:rPr sz="2300" b="0">
+              <a:rPr sz="2400" b="0">
                 <a:solidFill>
                   <a:srgbClr val="2C2C2C"/>
                 </a:solidFill>
@@ -7212,7 +7212,7 @@
               </a:spcAft>
             </a:pPr>
             <a:r>
-              <a:rPr sz="2300" b="1">
+              <a:rPr sz="2400" b="1">
                 <a:solidFill>
                   <a:srgbClr val="2C2C2C"/>
                 </a:solidFill>
@@ -7223,7 +7223,7 @@
               <a:t>목적 2.  </a:t>
             </a:r>
             <a:r>
-              <a:rPr sz="2300" b="0">
+              <a:rPr sz="2400" b="0">
                 <a:solidFill>
                   <a:srgbClr val="2C2C2C"/>
                 </a:solidFill>
@@ -7311,8 +7311,8 @@
         </p:nvSpPr>
         <p:spPr>
           <a:xfrm>
-            <a:off x="1980000" y="21348000"/>
-            <a:ext cx="12420000" cy="5400000"/>
+            <a:off x="1980000" y="21384000"/>
+            <a:ext cx="12420000" cy="6300000"/>
           </a:xfrm>
           <a:prstGeom prst="rect">
             <a:avLst/>
@@ -7334,7 +7334,7 @@
               <a:defRPr/>
             </a:pPr>
             <a:r>
-              <a:rPr sz="2300" b="0">
+              <a:rPr sz="2400" b="0">
                 <a:solidFill>
                   <a:srgbClr val="2C2C2C"/>
                 </a:solidFill>
@@ -7352,7 +7352,7 @@
               </a:spcAft>
             </a:pPr>
             <a:r>
-              <a:rPr sz="2300" b="0">
+              <a:rPr sz="2400" b="0">
                 <a:solidFill>
                   <a:srgbClr val="2C2C2C"/>
                 </a:solidFill>
@@ -7379,7 +7379,7 @@
         </p:nvSpPr>
         <p:spPr>
           <a:xfrm>
-            <a:off x="1980000" y="28908000"/>
+            <a:off x="1980000" y="29556000"/>
             <a:ext cx="12420000" cy="1620000"/>
           </a:xfrm>
           <a:prstGeom prst="rect">
@@ -7402,7 +7402,7 @@
               <a:defRPr/>
             </a:pPr>
             <a:r>
-              <a:rPr sz="2200" b="0">
+              <a:rPr sz="2400" b="0">
                 <a:solidFill>
                   <a:srgbClr val="2C2C2C"/>
                 </a:solidFill>
@@ -7452,7 +7452,7 @@
               <a:defRPr/>
             </a:pPr>
             <a:r>
-              <a:rPr sz="2300" b="1">
+              <a:rPr sz="2400" b="1">
                 <a:solidFill>
                   <a:srgbClr val="2C2C2C"/>
                 </a:solidFill>
@@ -7463,7 +7463,7 @@
               <a:t>함의:  </a:t>
             </a:r>
             <a:r>
-              <a:rPr sz="2300" b="0">
+              <a:rPr sz="2400" b="0">
                 <a:solidFill>
                   <a:srgbClr val="2C2C2C"/>
                 </a:solidFill>
@@ -7481,7 +7481,7 @@
               </a:spcAft>
             </a:pPr>
             <a:r>
-              <a:rPr sz="2300" b="1">
+              <a:rPr sz="2400" b="1">
                 <a:solidFill>
                   <a:srgbClr val="2C2C2C"/>
                 </a:solidFill>
@@ -7492,7 +7492,7 @@
               <a:t>한계:  </a:t>
             </a:r>
             <a:r>
-              <a:rPr sz="2300" b="0">
+              <a:rPr sz="2400" b="0">
                 <a:solidFill>
                   <a:srgbClr val="2C2C2C"/>
                 </a:solidFill>
@@ -7510,7 +7510,7 @@
               </a:spcAft>
             </a:pPr>
             <a:r>
-              <a:rPr sz="2300" b="1">
+              <a:rPr sz="2400" b="1">
                 <a:solidFill>
                   <a:srgbClr val="2C2C2C"/>
                 </a:solidFill>
@@ -7521,7 +7521,7 @@
               <a:t>전망:  </a:t>
             </a:r>
             <a:r>
-              <a:rPr sz="2300" b="0">
+              <a:rPr sz="2400" b="0">
                 <a:solidFill>
                   <a:srgbClr val="2C2C2C"/>
                 </a:solidFill>
@@ -7550,7 +7550,7 @@
         </p:blipFill>
         <p:spPr>
           <a:xfrm>
-            <a:off x="2016000" y="30672000"/>
+            <a:off x="2016000" y="31248000"/>
             <a:ext cx="12168000" cy="4306963"/>
           </a:xfrm>
           <a:prstGeom prst="rect">
@@ -7566,7 +7566,7 @@
         </p:nvSpPr>
         <p:spPr>
           <a:xfrm>
-            <a:off x="2016000" y="34992000"/>
+            <a:off x="2016000" y="35640000"/>
             <a:ext cx="12168000" cy="504000"/>
           </a:xfrm>
           <a:prstGeom prst="rect">
@@ -7608,8 +7608,8 @@
         </p:blipFill>
         <p:spPr>
           <a:xfrm>
-            <a:off x="4608000" y="35640000"/>
-            <a:ext cx="6552000" cy="3659837"/>
+            <a:off x="4788000" y="36144000"/>
+            <a:ext cx="6192000" cy="3458747"/>
           </a:xfrm>
           <a:prstGeom prst="rect">
             <a:avLst/>
@@ -7624,8 +7624,8 @@
         </p:nvSpPr>
         <p:spPr>
           <a:xfrm>
-            <a:off x="4608000" y="39420000"/>
-            <a:ext cx="6552000" cy="504000"/>
+            <a:off x="4788000" y="39672000"/>
+            <a:ext cx="6192000" cy="504000"/>
           </a:xfrm>
           <a:prstGeom prst="rect">
             <a:avLst/>
@@ -7666,8 +7666,8 @@
         </p:blipFill>
         <p:spPr>
           <a:xfrm>
-            <a:off x="16308000" y="10440000"/>
-            <a:ext cx="11880000" cy="4435200"/>
+            <a:off x="16488000" y="10440000"/>
+            <a:ext cx="11448000" cy="4273920"/>
           </a:xfrm>
           <a:prstGeom prst="rect">
             <a:avLst/>
@@ -8191,8 +8191,8 @@
         </p:blipFill>
         <p:spPr>
           <a:xfrm>
-            <a:off x="16560000" y="24192000"/>
-            <a:ext cx="10980000" cy="5690759"/>
+            <a:off x="16740000" y="24192000"/>
+            <a:ext cx="10800000" cy="5597468"/>
           </a:xfrm>
           <a:prstGeom prst="rect">
             <a:avLst/>

</xml_diff>